<commit_message>
Record robust hardcase training outcome
Constraint: V94 trained and scanned on the remote server with robust sensor noise, one-step action delay, and 0.9 action saturation while preserving the 80D/12D deployable ABI.
Rejected: Continuing the same robust-forward-left curriculum as a success path | V94 robust best/final still fail the mixed_vx_vy planar sign counterexample.
Confidence: medium
Scope-risk: narrow
Directive: Next repair should change the mixed vx/vy mechanism or staged residual constraints instead of only adding more timesteps to the same curriculum.
Tested: python scripts/create_worm_v6_advisor_update_ppt.py; python -m pytest src/v6/test_summarize_scan_acceptance_v6.py src/v6/test_reward_contract_v6.py src/v6/test_deployable_obs_v6.py src/v6/test_omni_eval_metrics_v6.py src/v6/test_visual_steel_strip_geometry_v6.py; git diff --check on touched paths.
Not-tested: New V94 videos were not recorded; this commit contains strict scan evidence and the updated advisor PPT.
</commit_message>
<xml_diff>
--- a/record/current/worm_v6_advisor_update_ppt/worm_v6_advisor_update_20260603.pptx
+++ b/record/current/worm_v6_advisor_update_ppt/worm_v6_advisor_update_20260603.pptx
@@ -3350,7 +3350,7 @@
                 </a:solidFill>
                 <a:latin typeface="Microsoft YaHei"/>
               </a:rPr>
-              <a:t>V93b nominal 通过但 robust mixed vx/vy 仍错号；V90/V92b 仍是当前汇报基线</a:t>
+              <a:t>V94 targeted 加训仍未修复 robust mixed vx/vy 错号；V90/V92b 仍是当前汇报基线</a:t>
             </a:r>
           </a:p>
         </p:txBody>
@@ -4896,6 +4896,22 @@
               </a:defRPr>
             </a:pPr>
             <a:r>
+              <a:t>V94 targeted robust-forward-left 加训仍失败，说明下一步不能只靠同类课程继续堆步数。</a:t>
+            </a:r>
+          </a:p>
+          <a:p>
+            <a:pPr>
+              <a:spcAft>
+                <a:spcPts val="288"/>
+              </a:spcAft>
+              <a:defRPr sz="1600">
+                <a:solidFill>
+                  <a:srgbClr val="191F24"/>
+                </a:solidFill>
+                <a:latin typeface="Microsoft YaHei"/>
+              </a:defRPr>
+            </a:pPr>
+            <a:r>
               <a:t>V50 componentwise mixed-command composition 不是默认方向，实验显示会增加 planar sign failure。</a:t>
             </a:r>
           </a:p>
@@ -5260,7 +5276,7 @@
                         </a:defRPr>
                       </a:pPr>
                       <a:r>
-                        <a:t>继续 mixed sign repair / gate ablation</a:t>
+                        <a:t>改 mixed sign repair 机制 / gate ablation</a:t>
                       </a:r>
                     </a:p>
                   </a:txBody>
@@ -5284,7 +5300,7 @@
                         </a:defRPr>
                       </a:pPr>
                       <a:r>
-                        <a:t>修 V92b/V93b robust 的 cmd=(0.05,0.075,0) 反向 vx</a:t>
+                        <a:t>V92b-V94 都指向 cmd=(0.05,0.075,0) 反向 vx</a:t>
                       </a:r>
                     </a:p>
                   </a:txBody>
@@ -9737,8 +9753,8 @@
         </p:nvSpPr>
         <p:spPr>
           <a:xfrm>
-            <a:off x="7178040" y="3977639"/>
-            <a:ext cx="4297680" cy="1234440"/>
+            <a:off x="7178040" y="3931920"/>
+            <a:ext cx="4297680" cy="1325880"/>
           </a:xfrm>
           <a:prstGeom prst="rect">
             <a:avLst/>
@@ -9755,7 +9771,7 @@
               <a:spcAft>
                 <a:spcPts val="288"/>
               </a:spcAft>
-              <a:defRPr sz="800">
+              <a:defRPr sz="700">
                 <a:solidFill>
                   <a:srgbClr val="5D676F"/>
                 </a:solidFill>
@@ -9771,7 +9787,7 @@
               <a:spcAft>
                 <a:spcPts val="288"/>
               </a:spcAft>
-              <a:defRPr sz="800">
+              <a:defRPr sz="700">
                 <a:solidFill>
                   <a:srgbClr val="5D676F"/>
                 </a:solidFill>
@@ -9787,7 +9803,7 @@
               <a:spcAft>
                 <a:spcPts val="288"/>
               </a:spcAft>
-              <a:defRPr sz="800">
+              <a:defRPr sz="700">
                 <a:solidFill>
                   <a:srgbClr val="5D676F"/>
                 </a:solidFill>
@@ -9795,7 +9811,7 @@
               </a:defRPr>
             </a:pPr>
             <a:r>
-              <a:t>V92b final_robust: planar RMSE 0.061 m/s, yaw RMSE 0.020 rad/s, planar/off-axis exceed 1/1.</a:t>
+              <a:t>V93b 已完成：best/final 的 nominal 均 accepted；best/final robust 均失败。</a:t>
             </a:r>
           </a:p>
           <a:p>
@@ -9803,7 +9819,7 @@
               <a:spcAft>
                 <a:spcPts val="288"/>
               </a:spcAft>
-              <a:defRPr sz="800">
+              <a:defRPr sz="700">
                 <a:solidFill>
                   <a:srgbClr val="5D676F"/>
                 </a:solidFill>
@@ -9811,7 +9827,7 @@
               </a:defRPr>
             </a:pPr>
             <a:r>
-              <a:t>V93b 已完成：best/final 的 nominal 均 accepted；best/final robust 均失败。</a:t>
+              <a:t>V94 已完成 targeted hardcase 训练和 scan：nominal 过，robust best/final 仍失败。</a:t>
             </a:r>
           </a:p>
           <a:p>
@@ -9819,7 +9835,7 @@
               <a:spcAft>
                 <a:spcPts val="288"/>
               </a:spcAft>
-              <a:defRPr sz="800">
+              <a:defRPr sz="700">
                 <a:solidFill>
                   <a:srgbClr val="5D676F"/>
                 </a:solidFill>
@@ -9827,7 +9843,7 @@
               </a:defRPr>
             </a:pPr>
             <a:r>
-              <a:t>失败条件非常集中：robust 下 cmd=(0.05, 0.075, 0) 出现负向 vx 投影，仍属 mixed_vx_vy counterexample。</a:t>
+              <a:t>结论：继续同类 hardcase 课程不足以修复 forward-left mixed sign，需要改先验/奖励结构或做分阶段残差约束。</a:t>
             </a:r>
           </a:p>
         </p:txBody>

</xml_diff>